<commit_message>
design(decks): re-engineer pitch deck and financial model with high-end executive typography, embedded graphics, and comparison matrix
</commit_message>
<xml_diff>
--- a/Bizora_Financial_Projections.pptx
+++ b/Bizora_Financial_Projections.pptx
@@ -6078,7 +6078,7 @@
             <a:avLst/>
           </a:prstGeom>
           <a:solidFill>
-            <a:srgbClr val="090D16"/>
+            <a:srgbClr val="0A0E17"/>
           </a:solidFill>
           <a:ln>
             <a:noFill/>
@@ -6108,103 +6108,20 @@
       </p:sp>
       <p:sp>
         <p:nvSpPr>
-          <p:cNvPr id="3" name="TextBox 2"/>
-          <p:cNvSpPr txBox="1"/>
-          <p:nvPr/>
-        </p:nvSpPr>
-        <p:spPr>
-          <a:xfrm>
-            <a:off x="914400" y="1828800"/>
-            <a:ext cx="10332720" cy="3200400"/>
-          </a:xfrm>
-          <a:prstGeom prst="rect">
-            <a:avLst/>
-          </a:prstGeom>
-          <a:noFill/>
-        </p:spPr>
-        <p:txBody>
-          <a:bodyPr wrap="none">
-            <a:spAutoFit/>
-          </a:bodyPr>
-          <a:lstStyle/>
-          <a:p>
-            <a:pPr>
-              <a:defRPr sz="4800" b="1">
-                <a:solidFill>
-                  <a:srgbClr val="F59E0B"/>
-                </a:solidFill>
-              </a:defRPr>
-            </a:pPr>
-            <a:r>
-              <a:t>BIZORA AI — FINANCIAL MODEL</a:t>
-            </a:r>
-          </a:p>
-          <a:p>
-            <a:pPr>
-              <a:spcBef>
-                <a:spcPts val="1200"/>
-              </a:spcBef>
-              <a:defRPr sz="2000" b="1">
-                <a:solidFill>
-                  <a:srgbClr val="F8FAFC"/>
-                </a:solidFill>
-              </a:defRPr>
-            </a:pPr>
-            <a:r>
-              <a:t>Unit Economics, 3-Year Projections, SaaS Margins &amp; Infrastructure Cost Analysis</a:t>
-            </a:r>
-          </a:p>
-          <a:p>
-            <a:pPr>
-              <a:spcBef>
-                <a:spcPts val="1200"/>
-              </a:spcBef>
-              <a:defRPr sz="1400">
-                <a:solidFill>
-                  <a:srgbClr val="94A3B8"/>
-                </a:solidFill>
-              </a:defRPr>
-            </a:pPr>
-            <a:r>
-              <a:t>Prepared for Investors, Judges, and Financial Review</a:t>
-            </a:r>
-          </a:p>
-        </p:txBody>
-      </p:sp>
-    </p:spTree>
-  </p:cSld>
-  <p:clrMapOvr>
-    <a:masterClrMapping/>
-  </p:clrMapOvr>
-</p:sld>
-</file>
-
-<file path=ppt/slides/slide2.xml><?xml version="1.0" encoding="utf-8"?>
-<p:sld xmlns:a="http://schemas.openxmlformats.org/drawingml/2006/main" xmlns:p="http://schemas.openxmlformats.org/presentationml/2006/main" xmlns:r="http://schemas.openxmlformats.org/officeDocument/2006/relationships">
-  <p:cSld>
-    <p:spTree>
-      <p:nvGrpSpPr>
-        <p:cNvPr id="1" name=""/>
-        <p:cNvGrpSpPr/>
-        <p:nvPr/>
-      </p:nvGrpSpPr>
-      <p:grpSpPr/>
-      <p:sp>
-        <p:nvSpPr>
-          <p:cNvPr id="2" name="Rectangle 1"/>
+          <p:cNvPr id="3" name="Rectangle 2"/>
           <p:cNvSpPr/>
           <p:nvPr/>
         </p:nvSpPr>
         <p:spPr>
           <a:xfrm>
             <a:off x="0" y="0"/>
-            <a:ext cx="12191695" cy="6858000"/>
+            <a:ext cx="12191695" cy="73152"/>
           </a:xfrm>
           <a:prstGeom prst="rect">
             <a:avLst/>
           </a:prstGeom>
           <a:solidFill>
-            <a:srgbClr val="090D16"/>
+            <a:srgbClr val="F59E0B"/>
           </a:solidFill>
           <a:ln>
             <a:noFill/>
@@ -6234,14 +6151,14 @@
       </p:sp>
       <p:sp>
         <p:nvSpPr>
-          <p:cNvPr id="3" name="TextBox 2"/>
+          <p:cNvPr id="4" name="TextBox 3"/>
           <p:cNvSpPr txBox="1"/>
           <p:nvPr/>
         </p:nvSpPr>
         <p:spPr>
           <a:xfrm>
-            <a:off x="731520" y="365760"/>
-            <a:ext cx="10515600" cy="320040"/>
+            <a:off x="914400" y="1645920"/>
+            <a:ext cx="10332720" cy="3657600"/>
           </a:xfrm>
           <a:prstGeom prst="rect">
             <a:avLst/>
@@ -6249,21 +6166,158 @@
           <a:noFill/>
         </p:spPr>
         <p:txBody>
-          <a:bodyPr wrap="none">
+          <a:bodyPr wrap="square">
             <a:spAutoFit/>
           </a:bodyPr>
           <a:lstStyle/>
           <a:p>
             <a:pPr>
-              <a:defRPr sz="1100" b="1">
+              <a:defRPr sz="5000" b="1">
                 <a:solidFill>
-                  <a:srgbClr val="38BDF8"/>
+                  <a:srgbClr val="F59E0B"/>
                 </a:solidFill>
+                <a:latin typeface="Trebuchet MS"/>
               </a:defRPr>
             </a:pPr>
             <a:r>
-              <a:t>FINANCIAL ARCHITECTURE</a:t>
-            </a:r>
+              <a:t>BIZORA AI — FINANCIAL MODEL</a:t>
+            </a:r>
+          </a:p>
+          <a:p>
+            <a:pPr>
+              <a:spcBef>
+                <a:spcPts val="1200"/>
+              </a:spcBef>
+              <a:defRPr sz="2200" b="1">
+                <a:solidFill>
+                  <a:srgbClr val="F8FAFC"/>
+                </a:solidFill>
+                <a:latin typeface="Trebuchet MS"/>
+              </a:defRPr>
+            </a:pPr>
+            <a:r>
+              <a:t>Unit Economics, 3-Year Projections, SaaS Margins &amp; Infrastructure Economics</a:t>
+            </a:r>
+          </a:p>
+          <a:p>
+            <a:pPr>
+              <a:spcBef>
+                <a:spcPts val="1200"/>
+              </a:spcBef>
+              <a:defRPr sz="1400">
+                <a:solidFill>
+                  <a:srgbClr val="94A3B8"/>
+                </a:solidFill>
+                <a:latin typeface="Segoe UI"/>
+              </a:defRPr>
+            </a:pPr>
+            <a:r>
+              <a:t>Prepared for Investors, Incubator Judges, and Financial Due Diligence</a:t>
+            </a:r>
+          </a:p>
+        </p:txBody>
+      </p:sp>
+    </p:spTree>
+  </p:cSld>
+  <p:clrMapOvr>
+    <a:masterClrMapping/>
+  </p:clrMapOvr>
+</p:sld>
+</file>
+
+<file path=ppt/slides/slide2.xml><?xml version="1.0" encoding="utf-8"?>
+<p:sld xmlns:a="http://schemas.openxmlformats.org/drawingml/2006/main" xmlns:p="http://schemas.openxmlformats.org/presentationml/2006/main" xmlns:r="http://schemas.openxmlformats.org/officeDocument/2006/relationships">
+  <p:cSld>
+    <p:spTree>
+      <p:nvGrpSpPr>
+        <p:cNvPr id="1" name=""/>
+        <p:cNvGrpSpPr/>
+        <p:nvPr/>
+      </p:nvGrpSpPr>
+      <p:grpSpPr/>
+      <p:sp>
+        <p:nvSpPr>
+          <p:cNvPr id="2" name="Rectangle 1"/>
+          <p:cNvSpPr/>
+          <p:nvPr/>
+        </p:nvSpPr>
+        <p:spPr>
+          <a:xfrm>
+            <a:off x="0" y="0"/>
+            <a:ext cx="12191695" cy="6858000"/>
+          </a:xfrm>
+          <a:prstGeom prst="rect">
+            <a:avLst/>
+          </a:prstGeom>
+          <a:solidFill>
+            <a:srgbClr val="0A0E17"/>
+          </a:solidFill>
+          <a:ln>
+            <a:noFill/>
+          </a:ln>
+        </p:spPr>
+        <p:style>
+          <a:lnRef idx="1">
+            <a:schemeClr val="accent1"/>
+          </a:lnRef>
+          <a:fillRef idx="3">
+            <a:schemeClr val="accent1"/>
+          </a:fillRef>
+          <a:effectRef idx="2">
+            <a:schemeClr val="accent1"/>
+          </a:effectRef>
+          <a:fontRef idx="minor">
+            <a:schemeClr val="lt1"/>
+          </a:fontRef>
+        </p:style>
+        <p:txBody>
+          <a:bodyPr rtlCol="0" anchor="ctr"/>
+          <a:lstStyle/>
+          <a:p>
+            <a:pPr algn="ctr"/>
+          </a:p>
+        </p:txBody>
+      </p:sp>
+      <p:sp>
+        <p:nvSpPr>
+          <p:cNvPr id="3" name="Rectangle 2"/>
+          <p:cNvSpPr/>
+          <p:nvPr/>
+        </p:nvSpPr>
+        <p:spPr>
+          <a:xfrm>
+            <a:off x="0" y="0"/>
+            <a:ext cx="12191695" cy="73152"/>
+          </a:xfrm>
+          <a:prstGeom prst="rect">
+            <a:avLst/>
+          </a:prstGeom>
+          <a:solidFill>
+            <a:srgbClr val="F59E0B"/>
+          </a:solidFill>
+          <a:ln>
+            <a:noFill/>
+          </a:ln>
+        </p:spPr>
+        <p:style>
+          <a:lnRef idx="1">
+            <a:schemeClr val="accent1"/>
+          </a:lnRef>
+          <a:fillRef idx="3">
+            <a:schemeClr val="accent1"/>
+          </a:fillRef>
+          <a:effectRef idx="2">
+            <a:schemeClr val="accent1"/>
+          </a:effectRef>
+          <a:fontRef idx="minor">
+            <a:schemeClr val="lt1"/>
+          </a:fontRef>
+        </p:style>
+        <p:txBody>
+          <a:bodyPr rtlCol="0" anchor="ctr"/>
+          <a:lstStyle/>
+          <a:p>
+            <a:pPr algn="ctr"/>
           </a:p>
         </p:txBody>
       </p:sp>
@@ -6275,8 +6329,8 @@
         </p:nvSpPr>
         <p:spPr>
           <a:xfrm>
-            <a:off x="731520" y="640080"/>
-            <a:ext cx="10515600" cy="731520"/>
+            <a:off x="731520" y="365760"/>
+            <a:ext cx="10698480" cy="274320"/>
           </a:xfrm>
           <a:prstGeom prst="rect">
             <a:avLst/>
@@ -6284,42 +6338,79 @@
           <a:noFill/>
         </p:spPr>
         <p:txBody>
-          <a:bodyPr wrap="none">
+          <a:bodyPr wrap="square">
             <a:spAutoFit/>
           </a:bodyPr>
           <a:lstStyle/>
           <a:p>
             <a:pPr>
-              <a:defRPr sz="2800" b="1">
+              <a:defRPr sz="1000" b="1">
+                <a:solidFill>
+                  <a:srgbClr val="38BDF8"/>
+                </a:solidFill>
+                <a:latin typeface="Segoe UI"/>
+              </a:defRPr>
+            </a:pPr>
+            <a:r>
+              <a:t>UNIT ECONOMICS</a:t>
+            </a:r>
+          </a:p>
+        </p:txBody>
+      </p:sp>
+      <p:sp>
+        <p:nvSpPr>
+          <p:cNvPr id="5" name="TextBox 4"/>
+          <p:cNvSpPr txBox="1"/>
+          <p:nvPr/>
+        </p:nvSpPr>
+        <p:spPr>
+          <a:xfrm>
+            <a:off x="731520" y="621792"/>
+            <a:ext cx="10698480" cy="640080"/>
+          </a:xfrm>
+          <a:prstGeom prst="rect">
+            <a:avLst/>
+          </a:prstGeom>
+          <a:noFill/>
+        </p:spPr>
+        <p:txBody>
+          <a:bodyPr wrap="square">
+            <a:spAutoFit/>
+          </a:bodyPr>
+          <a:lstStyle/>
+          <a:p>
+            <a:pPr>
+              <a:defRPr sz="2600" b="1">
                 <a:solidFill>
                   <a:srgbClr val="F8FAFC"/>
                 </a:solidFill>
+                <a:latin typeface="Trebuchet MS"/>
               </a:defRPr>
             </a:pPr>
             <a:r>
-              <a:t>Unit Economics: High LTV/CAC Ratio &amp; 82%+ Gross Margins</a:t>
-            </a:r>
-          </a:p>
-        </p:txBody>
-      </p:sp>
-      <p:sp>
-        <p:nvSpPr>
-          <p:cNvPr id="5" name="Rounded Rectangle 4"/>
+              <a:t>Unit Economics: World-Class 17x LTV/CAC &amp; 82%+ Gross Margins</a:t>
+            </a:r>
+          </a:p>
+        </p:txBody>
+      </p:sp>
+      <p:sp>
+        <p:nvSpPr>
+          <p:cNvPr id="6" name="Rounded Rectangle 5"/>
           <p:cNvSpPr/>
           <p:nvPr/>
         </p:nvSpPr>
         <p:spPr>
           <a:xfrm>
-            <a:off x="731520" y="2011680"/>
-            <a:ext cx="2560320" cy="3657600"/>
+            <a:off x="731520" y="1737360"/>
+            <a:ext cx="2560320" cy="4297680"/>
           </a:xfrm>
           <a:prstGeom prst="roundRect">
             <a:avLst/>
           </a:prstGeom>
           <a:solidFill>
-            <a:srgbClr val="0F172A"/>
+            <a:srgbClr val="101828"/>
           </a:solidFill>
-          <a:ln>
+          <a:ln w="25400">
             <a:solidFill>
               <a:srgbClr val="38BDF8"/>
             </a:solidFill>
@@ -6340,18 +6431,19 @@
           </a:fontRef>
         </p:style>
         <p:txBody>
-          <a:bodyPr rtlCol="0" anchor="ctr"/>
+          <a:bodyPr rtlCol="0" anchor="ctr" wrap="square"/>
           <a:lstStyle/>
           <a:p>
             <a:pPr algn="ctr">
-              <a:defRPr sz="2600" b="1">
+              <a:defRPr sz="1100" b="1">
                 <a:solidFill>
                   <a:srgbClr val="38BDF8"/>
                 </a:solidFill>
+                <a:latin typeface="Segoe UI"/>
               </a:defRPr>
             </a:pPr>
             <a:r>
-              <a:t>₹699 / mo</a:t>
+              <a:t>BLENDED ARPU</a:t>
             </a:r>
           </a:p>
           <a:p>
@@ -6359,25 +6451,27 @@
               <a:spcBef>
                 <a:spcPts val="1000"/>
               </a:spcBef>
-              <a:defRPr sz="1400" b="1">
+              <a:defRPr sz="2800" b="1">
                 <a:solidFill>
                   <a:srgbClr val="F8FAFC"/>
                 </a:solidFill>
+                <a:latin typeface="Trebuchet MS"/>
               </a:defRPr>
             </a:pPr>
             <a:r>
-              <a:t>Blended ARPU</a:t>
+              <a:t>₹699 / mo</a:t>
             </a:r>
           </a:p>
           <a:p>
             <a:pPr>
               <a:spcBef>
-                <a:spcPts val="1000"/>
+                <a:spcPts val="1400"/>
               </a:spcBef>
-              <a:defRPr sz="1100">
+              <a:defRPr sz="1200">
                 <a:solidFill>
                   <a:srgbClr val="94A3B8"/>
                 </a:solidFill>
+                <a:latin typeface="Segoe UI"/>
               </a:defRPr>
             </a:pPr>
             <a:r>
@@ -6388,190 +6482,22 @@
       </p:sp>
       <p:sp>
         <p:nvSpPr>
-          <p:cNvPr id="6" name="Rounded Rectangle 5"/>
+          <p:cNvPr id="7" name="Rounded Rectangle 6"/>
           <p:cNvSpPr/>
           <p:nvPr/>
         </p:nvSpPr>
         <p:spPr>
           <a:xfrm>
-            <a:off x="3429000" y="2011680"/>
-            <a:ext cx="2560320" cy="3657600"/>
+            <a:off x="3429000" y="1737360"/>
+            <a:ext cx="2560320" cy="4297680"/>
           </a:xfrm>
           <a:prstGeom prst="roundRect">
             <a:avLst/>
           </a:prstGeom>
           <a:solidFill>
-            <a:srgbClr val="0F172A"/>
+            <a:srgbClr val="101828"/>
           </a:solidFill>
-          <a:ln>
-            <a:solidFill>
-              <a:srgbClr val="38BDF8"/>
-            </a:solidFill>
-          </a:ln>
-        </p:spPr>
-        <p:style>
-          <a:lnRef idx="1">
-            <a:schemeClr val="accent1"/>
-          </a:lnRef>
-          <a:fillRef idx="3">
-            <a:schemeClr val="accent1"/>
-          </a:fillRef>
-          <a:effectRef idx="2">
-            <a:schemeClr val="accent1"/>
-          </a:effectRef>
-          <a:fontRef idx="minor">
-            <a:schemeClr val="lt1"/>
-          </a:fontRef>
-        </p:style>
-        <p:txBody>
-          <a:bodyPr rtlCol="0" anchor="ctr"/>
-          <a:lstStyle/>
-          <a:p>
-            <a:pPr algn="ctr">
-              <a:defRPr sz="2600" b="1">
-                <a:solidFill>
-                  <a:srgbClr val="38BDF8"/>
-                </a:solidFill>
-              </a:defRPr>
-            </a:pPr>
-            <a:r>
-              <a:t>₹850</a:t>
-            </a:r>
-          </a:p>
-          <a:p>
-            <a:pPr>
-              <a:spcBef>
-                <a:spcPts val="1000"/>
-              </a:spcBef>
-              <a:defRPr sz="1400" b="1">
-                <a:solidFill>
-                  <a:srgbClr val="F8FAFC"/>
-                </a:solidFill>
-              </a:defRPr>
-            </a:pPr>
-            <a:r>
-              <a:t>Blended CAC</a:t>
-            </a:r>
-          </a:p>
-          <a:p>
-            <a:pPr>
-              <a:spcBef>
-                <a:spcPts val="1000"/>
-              </a:spcBef>
-              <a:defRPr sz="1100">
-                <a:solidFill>
-                  <a:srgbClr val="94A3B8"/>
-                </a:solidFill>
-              </a:defRPr>
-            </a:pPr>
-            <a:r>
-              <a:t>Achieved via hyper-localized kirana community referrals and distributor partnerships.</a:t>
-            </a:r>
-          </a:p>
-        </p:txBody>
-      </p:sp>
-      <p:sp>
-        <p:nvSpPr>
-          <p:cNvPr id="7" name="Rounded Rectangle 6"/>
-          <p:cNvSpPr/>
-          <p:nvPr/>
-        </p:nvSpPr>
-        <p:spPr>
-          <a:xfrm>
-            <a:off x="6126480" y="2011680"/>
-            <a:ext cx="2560320" cy="3657600"/>
-          </a:xfrm>
-          <a:prstGeom prst="roundRect">
-            <a:avLst/>
-          </a:prstGeom>
-          <a:solidFill>
-            <a:srgbClr val="0F172A"/>
-          </a:solidFill>
-          <a:ln>
-            <a:solidFill>
-              <a:srgbClr val="38BDF8"/>
-            </a:solidFill>
-          </a:ln>
-        </p:spPr>
-        <p:style>
-          <a:lnRef idx="1">
-            <a:schemeClr val="accent1"/>
-          </a:lnRef>
-          <a:fillRef idx="3">
-            <a:schemeClr val="accent1"/>
-          </a:fillRef>
-          <a:effectRef idx="2">
-            <a:schemeClr val="accent1"/>
-          </a:effectRef>
-          <a:fontRef idx="minor">
-            <a:schemeClr val="lt1"/>
-          </a:fontRef>
-        </p:style>
-        <p:txBody>
-          <a:bodyPr rtlCol="0" anchor="ctr"/>
-          <a:lstStyle/>
-          <a:p>
-            <a:pPr algn="ctr">
-              <a:defRPr sz="2600" b="1">
-                <a:solidFill>
-                  <a:srgbClr val="38BDF8"/>
-                </a:solidFill>
-              </a:defRPr>
-            </a:pPr>
-            <a:r>
-              <a:t>₹14,500</a:t>
-            </a:r>
-          </a:p>
-          <a:p>
-            <a:pPr>
-              <a:spcBef>
-                <a:spcPts val="1000"/>
-              </a:spcBef>
-              <a:defRPr sz="1400" b="1">
-                <a:solidFill>
-                  <a:srgbClr val="F8FAFC"/>
-                </a:solidFill>
-              </a:defRPr>
-            </a:pPr>
-            <a:r>
-              <a:t>Customer Lifetime Value (LTV)</a:t>
-            </a:r>
-          </a:p>
-          <a:p>
-            <a:pPr>
-              <a:spcBef>
-                <a:spcPts val="1000"/>
-              </a:spcBef>
-              <a:defRPr sz="1100">
-                <a:solidFill>
-                  <a:srgbClr val="94A3B8"/>
-                </a:solidFill>
-              </a:defRPr>
-            </a:pPr>
-            <a:r>
-              <a:t>Assuming 24-month average store lifetime with under 3.5% monthly merchant churn.</a:t>
-            </a:r>
-          </a:p>
-        </p:txBody>
-      </p:sp>
-      <p:sp>
-        <p:nvSpPr>
-          <p:cNvPr id="8" name="Rounded Rectangle 7"/>
-          <p:cNvSpPr/>
-          <p:nvPr/>
-        </p:nvSpPr>
-        <p:spPr>
-          <a:xfrm>
-            <a:off x="8823960" y="2011680"/>
-            <a:ext cx="2560320" cy="3657600"/>
-          </a:xfrm>
-          <a:prstGeom prst="roundRect">
-            <a:avLst/>
-          </a:prstGeom>
-          <a:solidFill>
-            <a:srgbClr val="0F172A"/>
-          </a:solidFill>
-          <a:ln>
+          <a:ln w="25400">
             <a:solidFill>
               <a:srgbClr val="F59E0B"/>
             </a:solidFill>
@@ -6592,18 +6518,19 @@
           </a:fontRef>
         </p:style>
         <p:txBody>
-          <a:bodyPr rtlCol="0" anchor="ctr"/>
+          <a:bodyPr rtlCol="0" anchor="ctr" wrap="square"/>
           <a:lstStyle/>
           <a:p>
             <a:pPr algn="ctr">
-              <a:defRPr sz="2600" b="1">
+              <a:defRPr sz="1100" b="1">
                 <a:solidFill>
                   <a:srgbClr val="F59E0B"/>
                 </a:solidFill>
+                <a:latin typeface="Segoe UI"/>
               </a:defRPr>
             </a:pPr>
             <a:r>
-              <a:t>17.0x</a:t>
+              <a:t>BLENDED CAC</a:t>
             </a:r>
           </a:p>
           <a:p>
@@ -6611,14 +6538,86 @@
               <a:spcBef>
                 <a:spcPts val="1000"/>
               </a:spcBef>
-              <a:defRPr sz="1400" b="1">
+              <a:defRPr sz="2800" b="1">
                 <a:solidFill>
                   <a:srgbClr val="F8FAFC"/>
                 </a:solidFill>
+                <a:latin typeface="Trebuchet MS"/>
               </a:defRPr>
             </a:pPr>
             <a:r>
-              <a:t>LTV to CAC Ratio</a:t>
+              <a:t>₹850</a:t>
+            </a:r>
+          </a:p>
+          <a:p>
+            <a:pPr>
+              <a:spcBef>
+                <a:spcPts val="1400"/>
+              </a:spcBef>
+              <a:defRPr sz="1200">
+                <a:solidFill>
+                  <a:srgbClr val="94A3B8"/>
+                </a:solidFill>
+                <a:latin typeface="Segoe UI"/>
+              </a:defRPr>
+            </a:pPr>
+            <a:r>
+              <a:t>Achieved via hyper-localized kirana community referrals and distributor partnerships.</a:t>
+            </a:r>
+          </a:p>
+        </p:txBody>
+      </p:sp>
+      <p:sp>
+        <p:nvSpPr>
+          <p:cNvPr id="8" name="Rounded Rectangle 7"/>
+          <p:cNvSpPr/>
+          <p:nvPr/>
+        </p:nvSpPr>
+        <p:spPr>
+          <a:xfrm>
+            <a:off x="6126480" y="1737360"/>
+            <a:ext cx="2560320" cy="4297680"/>
+          </a:xfrm>
+          <a:prstGeom prst="roundRect">
+            <a:avLst/>
+          </a:prstGeom>
+          <a:solidFill>
+            <a:srgbClr val="101828"/>
+          </a:solidFill>
+          <a:ln w="25400">
+            <a:solidFill>
+              <a:srgbClr val="10B981"/>
+            </a:solidFill>
+          </a:ln>
+        </p:spPr>
+        <p:style>
+          <a:lnRef idx="1">
+            <a:schemeClr val="accent1"/>
+          </a:lnRef>
+          <a:fillRef idx="3">
+            <a:schemeClr val="accent1"/>
+          </a:fillRef>
+          <a:effectRef idx="2">
+            <a:schemeClr val="accent1"/>
+          </a:effectRef>
+          <a:fontRef idx="minor">
+            <a:schemeClr val="lt1"/>
+          </a:fontRef>
+        </p:style>
+        <p:txBody>
+          <a:bodyPr rtlCol="0" anchor="ctr" wrap="square"/>
+          <a:lstStyle/>
+          <a:p>
+            <a:pPr algn="ctr">
+              <a:defRPr sz="1100" b="1">
+                <a:solidFill>
+                  <a:srgbClr val="10B981"/>
+                </a:solidFill>
+                <a:latin typeface="Segoe UI"/>
+              </a:defRPr>
+            </a:pPr>
+            <a:r>
+              <a:t>CUSTOMER LIFETIME VALUE</a:t>
             </a:r>
           </a:p>
           <a:p>
@@ -6626,14 +6625,118 @@
               <a:spcBef>
                 <a:spcPts val="1000"/>
               </a:spcBef>
-              <a:defRPr sz="1100">
+              <a:defRPr sz="2800" b="1">
+                <a:solidFill>
+                  <a:srgbClr val="F8FAFC"/>
+                </a:solidFill>
+                <a:latin typeface="Trebuchet MS"/>
+              </a:defRPr>
+            </a:pPr>
+            <a:r>
+              <a:t>₹14,500</a:t>
+            </a:r>
+          </a:p>
+          <a:p>
+            <a:pPr>
+              <a:spcBef>
+                <a:spcPts val="1400"/>
+              </a:spcBef>
+              <a:defRPr sz="1200">
                 <a:solidFill>
                   <a:srgbClr val="94A3B8"/>
                 </a:solidFill>
+                <a:latin typeface="Segoe UI"/>
               </a:defRPr>
             </a:pPr>
             <a:r>
-              <a:t>World-class SaaS unit efficiency driven by word-of-mouth adoption among shopkeepers.</a:t>
+              <a:t>Assuming 24-month average store lifetime with under 3.5% monthly merchant churn.</a:t>
+            </a:r>
+          </a:p>
+        </p:txBody>
+      </p:sp>
+      <p:sp>
+        <p:nvSpPr>
+          <p:cNvPr id="9" name="Rounded Rectangle 8"/>
+          <p:cNvSpPr/>
+          <p:nvPr/>
+        </p:nvSpPr>
+        <p:spPr>
+          <a:xfrm>
+            <a:off x="8823960" y="1737360"/>
+            <a:ext cx="2560320" cy="4297680"/>
+          </a:xfrm>
+          <a:prstGeom prst="roundRect">
+            <a:avLst/>
+          </a:prstGeom>
+          <a:solidFill>
+            <a:srgbClr val="101828"/>
+          </a:solidFill>
+          <a:ln w="25400">
+            <a:solidFill>
+              <a:srgbClr val="FDE68A"/>
+            </a:solidFill>
+          </a:ln>
+        </p:spPr>
+        <p:style>
+          <a:lnRef idx="1">
+            <a:schemeClr val="accent1"/>
+          </a:lnRef>
+          <a:fillRef idx="3">
+            <a:schemeClr val="accent1"/>
+          </a:fillRef>
+          <a:effectRef idx="2">
+            <a:schemeClr val="accent1"/>
+          </a:effectRef>
+          <a:fontRef idx="minor">
+            <a:schemeClr val="lt1"/>
+          </a:fontRef>
+        </p:style>
+        <p:txBody>
+          <a:bodyPr rtlCol="0" anchor="ctr" wrap="square"/>
+          <a:lstStyle/>
+          <a:p>
+            <a:pPr algn="ctr">
+              <a:defRPr sz="1100" b="1">
+                <a:solidFill>
+                  <a:srgbClr val="FDE68A"/>
+                </a:solidFill>
+                <a:latin typeface="Segoe UI"/>
+              </a:defRPr>
+            </a:pPr>
+            <a:r>
+              <a:t>LTV / CAC RATIO</a:t>
+            </a:r>
+          </a:p>
+          <a:p>
+            <a:pPr>
+              <a:spcBef>
+                <a:spcPts val="1000"/>
+              </a:spcBef>
+              <a:defRPr sz="2800" b="1">
+                <a:solidFill>
+                  <a:srgbClr val="F8FAFC"/>
+                </a:solidFill>
+                <a:latin typeface="Trebuchet MS"/>
+              </a:defRPr>
+            </a:pPr>
+            <a:r>
+              <a:t>17.0x</a:t>
+            </a:r>
+          </a:p>
+          <a:p>
+            <a:pPr>
+              <a:spcBef>
+                <a:spcPts val="1400"/>
+              </a:spcBef>
+              <a:defRPr sz="1200">
+                <a:solidFill>
+                  <a:srgbClr val="94A3B8"/>
+                </a:solidFill>
+                <a:latin typeface="Segoe UI"/>
+              </a:defRPr>
+            </a:pPr>
+            <a:r>
+              <a:t>Exceptional SaaS capital efficiency driven by merchant viral adoption and word-of-mouth.</a:t>
             </a:r>
           </a:p>
         </p:txBody>
@@ -6671,7 +6774,7 @@
             <a:avLst/>
           </a:prstGeom>
           <a:solidFill>
-            <a:srgbClr val="090D16"/>
+            <a:srgbClr val="0A0E17"/>
           </a:solidFill>
           <a:ln>
             <a:noFill/>
@@ -6701,14 +6804,57 @@
       </p:sp>
       <p:sp>
         <p:nvSpPr>
-          <p:cNvPr id="3" name="TextBox 2"/>
+          <p:cNvPr id="3" name="Rectangle 2"/>
+          <p:cNvSpPr/>
+          <p:nvPr/>
+        </p:nvSpPr>
+        <p:spPr>
+          <a:xfrm>
+            <a:off x="0" y="0"/>
+            <a:ext cx="12191695" cy="73152"/>
+          </a:xfrm>
+          <a:prstGeom prst="rect">
+            <a:avLst/>
+          </a:prstGeom>
+          <a:solidFill>
+            <a:srgbClr val="F59E0B"/>
+          </a:solidFill>
+          <a:ln>
+            <a:noFill/>
+          </a:ln>
+        </p:spPr>
+        <p:style>
+          <a:lnRef idx="1">
+            <a:schemeClr val="accent1"/>
+          </a:lnRef>
+          <a:fillRef idx="3">
+            <a:schemeClr val="accent1"/>
+          </a:fillRef>
+          <a:effectRef idx="2">
+            <a:schemeClr val="accent1"/>
+          </a:effectRef>
+          <a:fontRef idx="minor">
+            <a:schemeClr val="lt1"/>
+          </a:fontRef>
+        </p:style>
+        <p:txBody>
+          <a:bodyPr rtlCol="0" anchor="ctr"/>
+          <a:lstStyle/>
+          <a:p>
+            <a:pPr algn="ctr"/>
+          </a:p>
+        </p:txBody>
+      </p:sp>
+      <p:sp>
+        <p:nvSpPr>
+          <p:cNvPr id="4" name="TextBox 3"/>
           <p:cNvSpPr txBox="1"/>
           <p:nvPr/>
         </p:nvSpPr>
         <p:spPr>
           <a:xfrm>
             <a:off x="731520" y="365760"/>
-            <a:ext cx="10515600" cy="320040"/>
+            <a:ext cx="10698480" cy="274320"/>
           </a:xfrm>
           <a:prstGeom prst="rect">
             <a:avLst/>
@@ -6716,34 +6862,35 @@
           <a:noFill/>
         </p:spPr>
         <p:txBody>
-          <a:bodyPr wrap="none">
+          <a:bodyPr wrap="square">
             <a:spAutoFit/>
           </a:bodyPr>
           <a:lstStyle/>
           <a:p>
             <a:pPr>
-              <a:defRPr sz="1100" b="1">
+              <a:defRPr sz="1000" b="1">
                 <a:solidFill>
                   <a:srgbClr val="38BDF8"/>
                 </a:solidFill>
+                <a:latin typeface="Segoe UI"/>
               </a:defRPr>
             </a:pPr>
             <a:r>
-              <a:t>PROJECTIONS</a:t>
-            </a:r>
-          </a:p>
-        </p:txBody>
-      </p:sp>
-      <p:sp>
-        <p:nvSpPr>
-          <p:cNvPr id="4" name="TextBox 3"/>
+              <a:t>FINANCIAL FORECAST</a:t>
+            </a:r>
+          </a:p>
+        </p:txBody>
+      </p:sp>
+      <p:sp>
+        <p:nvSpPr>
+          <p:cNvPr id="5" name="TextBox 4"/>
           <p:cNvSpPr txBox="1"/>
           <p:nvPr/>
         </p:nvSpPr>
         <p:spPr>
           <a:xfrm>
-            <a:off x="731520" y="640080"/>
-            <a:ext cx="10515600" cy="731520"/>
+            <a:off x="731520" y="621792"/>
+            <a:ext cx="10698480" cy="640080"/>
           </a:xfrm>
           <a:prstGeom prst="rect">
             <a:avLst/>
@@ -6751,35 +6898,36 @@
           <a:noFill/>
         </p:spPr>
         <p:txBody>
-          <a:bodyPr wrap="none">
+          <a:bodyPr wrap="square">
             <a:spAutoFit/>
           </a:bodyPr>
           <a:lstStyle/>
           <a:p>
             <a:pPr>
-              <a:defRPr sz="2800" b="1">
+              <a:defRPr sz="2600" b="1">
                 <a:solidFill>
                   <a:srgbClr val="F8FAFC"/>
                 </a:solidFill>
+                <a:latin typeface="Trebuchet MS"/>
               </a:defRPr>
             </a:pPr>
             <a:r>
-              <a:t>3-Year Financial &amp; Store Growth Projections</a:t>
+              <a:t>3-Year Growth &amp; Profitability Projections</a:t>
             </a:r>
           </a:p>
         </p:txBody>
       </p:sp>
       <p:graphicFrame>
         <p:nvGraphicFramePr>
-          <p:cNvPr id="5" name="Table 4"/>
+          <p:cNvPr id="6" name="Table 5"/>
           <p:cNvGraphicFramePr>
             <a:graphicFrameLocks noGrp="1"/>
           </p:cNvGraphicFramePr>
           <p:nvPr/>
         </p:nvGraphicFramePr>
         <p:xfrm>
-          <a:off x="731520" y="1828800"/>
-          <a:ext cx="10698480" cy="4114800"/>
+          <a:off x="731520" y="1645920"/>
+          <a:ext cx="10698480" cy="4389120"/>
         </p:xfrm>
         <a:graphic>
           <a:graphicData uri="http://schemas.openxmlformats.org/drawingml/2006/table">
@@ -6793,7 +6941,7 @@
                 <a:gridCol w="2674620"/>
                 <a:gridCol w="2674620"/>
               </a:tblGrid>
-              <a:tr h="685800">
+              <a:tr h="731520">
                 <a:tc>
                   <a:txBody>
                     <a:bodyPr/>
@@ -6804,16 +6952,17 @@
                           <a:solidFill>
                             <a:srgbClr val="F59E0B"/>
                           </a:solidFill>
+                          <a:latin typeface="Trebuchet MS"/>
                         </a:defRPr>
                       </a:pPr>
                       <a:r>
-                        <a:t>Metric / KPI</a:t>
+                        <a:t>Financial Metric</a:t>
                       </a:r>
                     </a:p>
                   </a:txBody>
                   <a:tcPr>
                     <a:solidFill>
-                      <a:srgbClr val="1E293B"/>
+                      <a:srgbClr val="182238"/>
                     </a:solidFill>
                   </a:tcPr>
                 </a:tc>
@@ -6827,16 +6976,17 @@
                           <a:solidFill>
                             <a:srgbClr val="F59E0B"/>
                           </a:solidFill>
+                          <a:latin typeface="Trebuchet MS"/>
                         </a:defRPr>
                       </a:pPr>
                       <a:r>
-                        <a:t>Year 1 (Launch &amp; Scale)</a:t>
+                        <a:t>Year 1 (Scale Launch)</a:t>
                       </a:r>
                     </a:p>
                   </a:txBody>
                   <a:tcPr>
                     <a:solidFill>
-                      <a:srgbClr val="1E293B"/>
+                      <a:srgbClr val="182238"/>
                     </a:solidFill>
                   </a:tcPr>
                 </a:tc>
@@ -6850,16 +7000,17 @@
                           <a:solidFill>
                             <a:srgbClr val="F59E0B"/>
                           </a:solidFill>
+                          <a:latin typeface="Trebuchet MS"/>
                         </a:defRPr>
                       </a:pPr>
                       <a:r>
-                        <a:t>Year 2 (Expansion)</a:t>
+                        <a:t>Year 2 (Regional Expansion)</a:t>
                       </a:r>
                     </a:p>
                   </a:txBody>
                   <a:tcPr>
                     <a:solidFill>
-                      <a:srgbClr val="1E293B"/>
+                      <a:srgbClr val="182238"/>
                     </a:solidFill>
                   </a:tcPr>
                 </a:tc>
@@ -6873,6 +7024,7 @@
                           <a:solidFill>
                             <a:srgbClr val="F59E0B"/>
                           </a:solidFill>
+                          <a:latin typeface="Trebuchet MS"/>
                         </a:defRPr>
                       </a:pPr>
                       <a:r>
@@ -6882,22 +7034,23 @@
                   </a:txBody>
                   <a:tcPr>
                     <a:solidFill>
-                      <a:srgbClr val="1E293B"/>
+                      <a:srgbClr val="182238"/>
                     </a:solidFill>
                   </a:tcPr>
                 </a:tc>
               </a:tr>
-              <a:tr h="685800">
+              <a:tr h="731520">
                 <a:tc>
                   <a:txBody>
                     <a:bodyPr/>
                     <a:lstStyle/>
                     <a:p>
                       <a:pPr>
-                        <a:defRPr sz="1200">
+                        <a:defRPr sz="1200" b="1">
                           <a:solidFill>
                             <a:srgbClr val="38BDF8"/>
                           </a:solidFill>
+                          <a:latin typeface="Segoe UI"/>
                         </a:defRPr>
                       </a:pPr>
                       <a:r>
@@ -6907,7 +7060,7 @@
                   </a:txBody>
                   <a:tcPr>
                     <a:solidFill>
-                      <a:srgbClr val="0F172A"/>
+                      <a:srgbClr val="101828"/>
                     </a:solidFill>
                   </a:tcPr>
                 </a:tc>
@@ -6917,10 +7070,11 @@
                     <a:lstStyle/>
                     <a:p>
                       <a:pPr>
-                        <a:defRPr sz="1200">
+                        <a:defRPr sz="1200" b="0">
                           <a:solidFill>
                             <a:srgbClr val="F8FAFC"/>
                           </a:solidFill>
+                          <a:latin typeface="Segoe UI"/>
                         </a:defRPr>
                       </a:pPr>
                       <a:r>
@@ -6930,7 +7084,7 @@
                   </a:txBody>
                   <a:tcPr>
                     <a:solidFill>
-                      <a:srgbClr val="0F172A"/>
+                      <a:srgbClr val="101828"/>
                     </a:solidFill>
                   </a:tcPr>
                 </a:tc>
@@ -6940,10 +7094,11 @@
                     <a:lstStyle/>
                     <a:p>
                       <a:pPr>
-                        <a:defRPr sz="1200">
+                        <a:defRPr sz="1200" b="0">
                           <a:solidFill>
                             <a:srgbClr val="F8FAFC"/>
                           </a:solidFill>
+                          <a:latin typeface="Segoe UI"/>
                         </a:defRPr>
                       </a:pPr>
                       <a:r>
@@ -6953,7 +7108,7 @@
                   </a:txBody>
                   <a:tcPr>
                     <a:solidFill>
-                      <a:srgbClr val="0F172A"/>
+                      <a:srgbClr val="101828"/>
                     </a:solidFill>
                   </a:tcPr>
                 </a:tc>
@@ -6963,10 +7118,11 @@
                     <a:lstStyle/>
                     <a:p>
                       <a:pPr>
-                        <a:defRPr sz="1200">
+                        <a:defRPr sz="1200" b="0">
                           <a:solidFill>
                             <a:srgbClr val="F8FAFC"/>
                           </a:solidFill>
+                          <a:latin typeface="Segoe UI"/>
                         </a:defRPr>
                       </a:pPr>
                       <a:r>
@@ -6976,32 +7132,33 @@
                   </a:txBody>
                   <a:tcPr>
                     <a:solidFill>
-                      <a:srgbClr val="0F172A"/>
+                      <a:srgbClr val="101828"/>
                     </a:solidFill>
                   </a:tcPr>
                 </a:tc>
               </a:tr>
-              <a:tr h="685800">
+              <a:tr h="731520">
                 <a:tc>
                   <a:txBody>
                     <a:bodyPr/>
                     <a:lstStyle/>
                     <a:p>
                       <a:pPr>
-                        <a:defRPr sz="1200">
+                        <a:defRPr sz="1200" b="1">
                           <a:solidFill>
                             <a:srgbClr val="38BDF8"/>
                           </a:solidFill>
+                          <a:latin typeface="Segoe UI"/>
                         </a:defRPr>
                       </a:pPr>
                       <a:r>
-                        <a:t>Paying Stores (SaaS)</a:t>
+                        <a:t>Paying Stores (SaaS Conversion)</a:t>
                       </a:r>
                     </a:p>
                   </a:txBody>
                   <a:tcPr>
                     <a:solidFill>
-                      <a:srgbClr val="0F172A"/>
+                      <a:srgbClr val="101828"/>
                     </a:solidFill>
                   </a:tcPr>
                 </a:tc>
@@ -7011,10 +7168,11 @@
                     <a:lstStyle/>
                     <a:p>
                       <a:pPr>
-                        <a:defRPr sz="1200">
+                        <a:defRPr sz="1200" b="0">
                           <a:solidFill>
                             <a:srgbClr val="F8FAFC"/>
                           </a:solidFill>
+                          <a:latin typeface="Segoe UI"/>
                         </a:defRPr>
                       </a:pPr>
                       <a:r>
@@ -7024,7 +7182,7 @@
                   </a:txBody>
                   <a:tcPr>
                     <a:solidFill>
-                      <a:srgbClr val="0F172A"/>
+                      <a:srgbClr val="101828"/>
                     </a:solidFill>
                   </a:tcPr>
                 </a:tc>
@@ -7034,10 +7192,11 @@
                     <a:lstStyle/>
                     <a:p>
                       <a:pPr>
-                        <a:defRPr sz="1200">
+                        <a:defRPr sz="1200" b="0">
                           <a:solidFill>
                             <a:srgbClr val="F8FAFC"/>
                           </a:solidFill>
+                          <a:latin typeface="Segoe UI"/>
                         </a:defRPr>
                       </a:pPr>
                       <a:r>
@@ -7047,7 +7206,7 @@
                   </a:txBody>
                   <a:tcPr>
                     <a:solidFill>
-                      <a:srgbClr val="0F172A"/>
+                      <a:srgbClr val="101828"/>
                     </a:solidFill>
                   </a:tcPr>
                 </a:tc>
@@ -7057,10 +7216,11 @@
                     <a:lstStyle/>
                     <a:p>
                       <a:pPr>
-                        <a:defRPr sz="1200">
+                        <a:defRPr sz="1200" b="0">
                           <a:solidFill>
                             <a:srgbClr val="F8FAFC"/>
                           </a:solidFill>
+                          <a:latin typeface="Segoe UI"/>
                         </a:defRPr>
                       </a:pPr>
                       <a:r>
@@ -7070,22 +7230,23 @@
                   </a:txBody>
                   <a:tcPr>
                     <a:solidFill>
-                      <a:srgbClr val="0F172A"/>
+                      <a:srgbClr val="101828"/>
                     </a:solidFill>
                   </a:tcPr>
                 </a:tc>
               </a:tr>
-              <a:tr h="685800">
+              <a:tr h="731520">
                 <a:tc>
                   <a:txBody>
                     <a:bodyPr/>
                     <a:lstStyle/>
                     <a:p>
                       <a:pPr>
-                        <a:defRPr sz="1200">
+                        <a:defRPr sz="1200" b="1">
                           <a:solidFill>
                             <a:srgbClr val="38BDF8"/>
                           </a:solidFill>
+                          <a:latin typeface="Segoe UI"/>
                         </a:defRPr>
                       </a:pPr>
                       <a:r>
@@ -7095,7 +7256,7 @@
                   </a:txBody>
                   <a:tcPr>
                     <a:solidFill>
-                      <a:srgbClr val="0F172A"/>
+                      <a:srgbClr val="101828"/>
                     </a:solidFill>
                   </a:tcPr>
                 </a:tc>
@@ -7105,10 +7266,11 @@
                     <a:lstStyle/>
                     <a:p>
                       <a:pPr>
-                        <a:defRPr sz="1200">
+                        <a:defRPr sz="1200" b="0">
                           <a:solidFill>
                             <a:srgbClr val="F8FAFC"/>
                           </a:solidFill>
+                          <a:latin typeface="Segoe UI"/>
                         </a:defRPr>
                       </a:pPr>
                       <a:r>
@@ -7118,7 +7280,7 @@
                   </a:txBody>
                   <a:tcPr>
                     <a:solidFill>
-                      <a:srgbClr val="0F172A"/>
+                      <a:srgbClr val="101828"/>
                     </a:solidFill>
                   </a:tcPr>
                 </a:tc>
@@ -7128,10 +7290,11 @@
                     <a:lstStyle/>
                     <a:p>
                       <a:pPr>
-                        <a:defRPr sz="1200">
+                        <a:defRPr sz="1200" b="0">
                           <a:solidFill>
                             <a:srgbClr val="F8FAFC"/>
                           </a:solidFill>
+                          <a:latin typeface="Segoe UI"/>
                         </a:defRPr>
                       </a:pPr>
                       <a:r>
@@ -7141,7 +7304,7 @@
                   </a:txBody>
                   <a:tcPr>
                     <a:solidFill>
-                      <a:srgbClr val="0F172A"/>
+                      <a:srgbClr val="101828"/>
                     </a:solidFill>
                   </a:tcPr>
                 </a:tc>
@@ -7151,10 +7314,11 @@
                     <a:lstStyle/>
                     <a:p>
                       <a:pPr>
-                        <a:defRPr sz="1200">
+                        <a:defRPr sz="1200" b="0">
                           <a:solidFill>
                             <a:srgbClr val="F8FAFC"/>
                           </a:solidFill>
+                          <a:latin typeface="Segoe UI"/>
                         </a:defRPr>
                       </a:pPr>
                       <a:r>
@@ -7164,22 +7328,23 @@
                   </a:txBody>
                   <a:tcPr>
                     <a:solidFill>
-                      <a:srgbClr val="0F172A"/>
+                      <a:srgbClr val="101828"/>
                     </a:solidFill>
                   </a:tcPr>
                 </a:tc>
               </a:tr>
-              <a:tr h="685800">
+              <a:tr h="731520">
                 <a:tc>
                   <a:txBody>
                     <a:bodyPr/>
                     <a:lstStyle/>
                     <a:p>
                       <a:pPr>
-                        <a:defRPr sz="1200">
+                        <a:defRPr sz="1200" b="1">
                           <a:solidFill>
                             <a:srgbClr val="38BDF8"/>
                           </a:solidFill>
+                          <a:latin typeface="Segoe UI"/>
                         </a:defRPr>
                       </a:pPr>
                       <a:r>
@@ -7189,7 +7354,7 @@
                   </a:txBody>
                   <a:tcPr>
                     <a:solidFill>
-                      <a:srgbClr val="0F172A"/>
+                      <a:srgbClr val="101828"/>
                     </a:solidFill>
                   </a:tcPr>
                 </a:tc>
@@ -7199,10 +7364,11 @@
                     <a:lstStyle/>
                     <a:p>
                       <a:pPr>
-                        <a:defRPr sz="1200">
+                        <a:defRPr sz="1200" b="0">
                           <a:solidFill>
                             <a:srgbClr val="F8FAFC"/>
                           </a:solidFill>
+                          <a:latin typeface="Segoe UI"/>
                         </a:defRPr>
                       </a:pPr>
                       <a:r>
@@ -7212,7 +7378,7 @@
                   </a:txBody>
                   <a:tcPr>
                     <a:solidFill>
-                      <a:srgbClr val="0F172A"/>
+                      <a:srgbClr val="101828"/>
                     </a:solidFill>
                   </a:tcPr>
                 </a:tc>
@@ -7222,10 +7388,11 @@
                     <a:lstStyle/>
                     <a:p>
                       <a:pPr>
-                        <a:defRPr sz="1200">
+                        <a:defRPr sz="1200" b="0">
                           <a:solidFill>
                             <a:srgbClr val="F8FAFC"/>
                           </a:solidFill>
+                          <a:latin typeface="Segoe UI"/>
                         </a:defRPr>
                       </a:pPr>
                       <a:r>
@@ -7235,7 +7402,7 @@
                   </a:txBody>
                   <a:tcPr>
                     <a:solidFill>
-                      <a:srgbClr val="0F172A"/>
+                      <a:srgbClr val="101828"/>
                     </a:solidFill>
                   </a:tcPr>
                 </a:tc>
@@ -7245,10 +7412,11 @@
                     <a:lstStyle/>
                     <a:p>
                       <a:pPr>
-                        <a:defRPr sz="1200">
+                        <a:defRPr sz="1200" b="0">
                           <a:solidFill>
                             <a:srgbClr val="F8FAFC"/>
                           </a:solidFill>
+                          <a:latin typeface="Segoe UI"/>
                         </a:defRPr>
                       </a:pPr>
                       <a:r>
@@ -7258,22 +7426,23 @@
                   </a:txBody>
                   <a:tcPr>
                     <a:solidFill>
-                      <a:srgbClr val="0F172A"/>
+                      <a:srgbClr val="101828"/>
                     </a:solidFill>
                   </a:tcPr>
                 </a:tc>
               </a:tr>
-              <a:tr h="685800">
+              <a:tr h="731520">
                 <a:tc>
                   <a:txBody>
                     <a:bodyPr/>
                     <a:lstStyle/>
                     <a:p>
                       <a:pPr>
-                        <a:defRPr sz="1200">
+                        <a:defRPr sz="1200" b="1">
                           <a:solidFill>
                             <a:srgbClr val="38BDF8"/>
                           </a:solidFill>
+                          <a:latin typeface="Segoe UI"/>
                         </a:defRPr>
                       </a:pPr>
                       <a:r>
@@ -7283,7 +7452,7 @@
                   </a:txBody>
                   <a:tcPr>
                     <a:solidFill>
-                      <a:srgbClr val="0F172A"/>
+                      <a:srgbClr val="101828"/>
                     </a:solidFill>
                   </a:tcPr>
                 </a:tc>
@@ -7293,10 +7462,11 @@
                     <a:lstStyle/>
                     <a:p>
                       <a:pPr>
-                        <a:defRPr sz="1200">
+                        <a:defRPr sz="1200" b="0">
                           <a:solidFill>
-                            <a:srgbClr val="F8FAFC"/>
+                            <a:srgbClr val="10B981"/>
                           </a:solidFill>
+                          <a:latin typeface="Segoe UI"/>
                         </a:defRPr>
                       </a:pPr>
                       <a:r>
@@ -7306,7 +7476,7 @@
                   </a:txBody>
                   <a:tcPr>
                     <a:solidFill>
-                      <a:srgbClr val="0F172A"/>
+                      <a:srgbClr val="101828"/>
                     </a:solidFill>
                   </a:tcPr>
                 </a:tc>
@@ -7316,10 +7486,11 @@
                     <a:lstStyle/>
                     <a:p>
                       <a:pPr>
-                        <a:defRPr sz="1200">
+                        <a:defRPr sz="1200" b="0">
                           <a:solidFill>
-                            <a:srgbClr val="F8FAFC"/>
+                            <a:srgbClr val="10B981"/>
                           </a:solidFill>
+                          <a:latin typeface="Segoe UI"/>
                         </a:defRPr>
                       </a:pPr>
                       <a:r>
@@ -7329,7 +7500,7 @@
                   </a:txBody>
                   <a:tcPr>
                     <a:solidFill>
-                      <a:srgbClr val="0F172A"/>
+                      <a:srgbClr val="101828"/>
                     </a:solidFill>
                   </a:tcPr>
                 </a:tc>
@@ -7339,10 +7510,11 @@
                     <a:lstStyle/>
                     <a:p>
                       <a:pPr>
-                        <a:defRPr sz="1200">
+                        <a:defRPr sz="1200" b="0">
                           <a:solidFill>
-                            <a:srgbClr val="F8FAFC"/>
+                            <a:srgbClr val="10B981"/>
                           </a:solidFill>
+                          <a:latin typeface="Segoe UI"/>
                         </a:defRPr>
                       </a:pPr>
                       <a:r>
@@ -7352,7 +7524,7 @@
                   </a:txBody>
                   <a:tcPr>
                     <a:solidFill>
-                      <a:srgbClr val="0F172A"/>
+                      <a:srgbClr val="101828"/>
                     </a:solidFill>
                   </a:tcPr>
                 </a:tc>
@@ -7394,7 +7566,7 @@
             <a:avLst/>
           </a:prstGeom>
           <a:solidFill>
-            <a:srgbClr val="090D16"/>
+            <a:srgbClr val="0A0E17"/>
           </a:solidFill>
           <a:ln>
             <a:noFill/>
@@ -7424,14 +7596,57 @@
       </p:sp>
       <p:sp>
         <p:nvSpPr>
-          <p:cNvPr id="3" name="TextBox 2"/>
+          <p:cNvPr id="3" name="Rectangle 2"/>
+          <p:cNvSpPr/>
+          <p:nvPr/>
+        </p:nvSpPr>
+        <p:spPr>
+          <a:xfrm>
+            <a:off x="0" y="0"/>
+            <a:ext cx="12191695" cy="73152"/>
+          </a:xfrm>
+          <a:prstGeom prst="rect">
+            <a:avLst/>
+          </a:prstGeom>
+          <a:solidFill>
+            <a:srgbClr val="F59E0B"/>
+          </a:solidFill>
+          <a:ln>
+            <a:noFill/>
+          </a:ln>
+        </p:spPr>
+        <p:style>
+          <a:lnRef idx="1">
+            <a:schemeClr val="accent1"/>
+          </a:lnRef>
+          <a:fillRef idx="3">
+            <a:schemeClr val="accent1"/>
+          </a:fillRef>
+          <a:effectRef idx="2">
+            <a:schemeClr val="accent1"/>
+          </a:effectRef>
+          <a:fontRef idx="minor">
+            <a:schemeClr val="lt1"/>
+          </a:fontRef>
+        </p:style>
+        <p:txBody>
+          <a:bodyPr rtlCol="0" anchor="ctr"/>
+          <a:lstStyle/>
+          <a:p>
+            <a:pPr algn="ctr"/>
+          </a:p>
+        </p:txBody>
+      </p:sp>
+      <p:sp>
+        <p:nvSpPr>
+          <p:cNvPr id="4" name="TextBox 3"/>
           <p:cNvSpPr txBox="1"/>
           <p:nvPr/>
         </p:nvSpPr>
         <p:spPr>
           <a:xfrm>
             <a:off x="731520" y="365760"/>
-            <a:ext cx="10515600" cy="320040"/>
+            <a:ext cx="10698480" cy="274320"/>
           </a:xfrm>
           <a:prstGeom prst="rect">
             <a:avLst/>
@@ -7439,34 +7654,35 @@
           <a:noFill/>
         </p:spPr>
         <p:txBody>
-          <a:bodyPr wrap="none">
+          <a:bodyPr wrap="square">
             <a:spAutoFit/>
           </a:bodyPr>
           <a:lstStyle/>
           <a:p>
             <a:pPr>
-              <a:defRPr sz="1100" b="1">
+              <a:defRPr sz="1000" b="1">
                 <a:solidFill>
                   <a:srgbClr val="38BDF8"/>
                 </a:solidFill>
+                <a:latin typeface="Segoe UI"/>
               </a:defRPr>
             </a:pPr>
             <a:r>
-              <a:t>CLOUD ECONOMICS</a:t>
-            </a:r>
-          </a:p>
-        </p:txBody>
-      </p:sp>
-      <p:sp>
-        <p:nvSpPr>
-          <p:cNvPr id="4" name="TextBox 3"/>
+              <a:t>INFRASTRUCTURE COSTS</a:t>
+            </a:r>
+          </a:p>
+        </p:txBody>
+      </p:sp>
+      <p:sp>
+        <p:nvSpPr>
+          <p:cNvPr id="5" name="TextBox 4"/>
           <p:cNvSpPr txBox="1"/>
           <p:nvPr/>
         </p:nvSpPr>
         <p:spPr>
           <a:xfrm>
-            <a:off x="731520" y="640080"/>
-            <a:ext cx="10515600" cy="731520"/>
+            <a:off x="731520" y="621792"/>
+            <a:ext cx="10698480" cy="640080"/>
           </a:xfrm>
           <a:prstGeom prst="rect">
             <a:avLst/>
@@ -7474,27 +7690,28 @@
           <a:noFill/>
         </p:spPr>
         <p:txBody>
-          <a:bodyPr wrap="none">
+          <a:bodyPr wrap="square">
             <a:spAutoFit/>
           </a:bodyPr>
           <a:lstStyle/>
           <a:p>
             <a:pPr>
-              <a:defRPr sz="2800" b="1">
+              <a:defRPr sz="2600" b="1">
                 <a:solidFill>
                   <a:srgbClr val="F8FAFC"/>
                 </a:solidFill>
+                <a:latin typeface="Trebuchet MS"/>
               </a:defRPr>
             </a:pPr>
             <a:r>
-              <a:t>Cloud Infrastructure Cost Analysis: Predictable &amp; Lean</a:t>
-            </a:r>
-          </a:p>
-        </p:txBody>
-      </p:sp>
-      <p:sp>
-        <p:nvSpPr>
-          <p:cNvPr id="5" name="Rounded Rectangle 4"/>
+              <a:t>Cloud Infrastructure Cost Analysis: Lean &amp; Highly Scalable</a:t>
+            </a:r>
+          </a:p>
+        </p:txBody>
+      </p:sp>
+      <p:sp>
+        <p:nvSpPr>
+          <p:cNvPr id="6" name="Rounded Rectangle 5"/>
           <p:cNvSpPr/>
           <p:nvPr/>
         </p:nvSpPr>
@@ -7507,7 +7724,7 @@
             <a:avLst/>
           </a:prstGeom>
           <a:solidFill>
-            <a:srgbClr val="0F172A"/>
+            <a:srgbClr val="101828"/>
           </a:solidFill>
           <a:ln>
             <a:solidFill>
@@ -7530,7 +7747,7 @@
           </a:fontRef>
         </p:style>
         <p:txBody>
-          <a:bodyPr rtlCol="0" anchor="ctr"/>
+          <a:bodyPr rtlCol="0" anchor="ctr" wrap="square"/>
           <a:lstStyle/>
           <a:p>
             <a:pPr algn="ctr">
@@ -7538,10 +7755,11 @@
                 <a:solidFill>
                   <a:srgbClr val="F59E0B"/>
                 </a:solidFill>
+                <a:latin typeface="Trebuchet MS"/>
               </a:defRPr>
             </a:pPr>
             <a:r>
-              <a:t>Render Web Services — $35 / mo (5 portals @ $7/mo)</a:t>
+              <a:t>Render Web Compute — $35 / mo (5 portals @ $7/mo)</a:t>
             </a:r>
           </a:p>
           <a:p>
@@ -7553,6 +7771,7 @@
                 <a:solidFill>
                   <a:srgbClr val="94A3B8"/>
                 </a:solidFill>
+                <a:latin typeface="Segoe UI"/>
               </a:defRPr>
             </a:pPr>
             <a:r>
@@ -7563,7 +7782,7 @@
       </p:sp>
       <p:sp>
         <p:nvSpPr>
-          <p:cNvPr id="6" name="Rounded Rectangle 5"/>
+          <p:cNvPr id="7" name="Rounded Rectangle 6"/>
           <p:cNvSpPr/>
           <p:nvPr/>
         </p:nvSpPr>
@@ -7576,7 +7795,7 @@
             <a:avLst/>
           </a:prstGeom>
           <a:solidFill>
-            <a:srgbClr val="0F172A"/>
+            <a:srgbClr val="101828"/>
           </a:solidFill>
           <a:ln>
             <a:solidFill>
@@ -7599,7 +7818,7 @@
           </a:fontRef>
         </p:style>
         <p:txBody>
-          <a:bodyPr rtlCol="0" anchor="ctr"/>
+          <a:bodyPr rtlCol="0" anchor="ctr" wrap="square"/>
           <a:lstStyle/>
           <a:p>
             <a:pPr algn="ctr">
@@ -7607,6 +7826,7 @@
                 <a:solidFill>
                   <a:srgbClr val="F59E0B"/>
                 </a:solidFill>
+                <a:latin typeface="Trebuchet MS"/>
               </a:defRPr>
             </a:pPr>
             <a:r>
@@ -7622,6 +7842,7 @@
                 <a:solidFill>
                   <a:srgbClr val="94A3B8"/>
                 </a:solidFill>
+                <a:latin typeface="Segoe UI"/>
               </a:defRPr>
             </a:pPr>
             <a:r>
@@ -7632,7 +7853,7 @@
       </p:sp>
       <p:sp>
         <p:nvSpPr>
-          <p:cNvPr id="7" name="Rounded Rectangle 6"/>
+          <p:cNvPr id="8" name="Rounded Rectangle 7"/>
           <p:cNvSpPr/>
           <p:nvPr/>
         </p:nvSpPr>
@@ -7645,7 +7866,7 @@
             <a:avLst/>
           </a:prstGeom>
           <a:solidFill>
-            <a:srgbClr val="0F172A"/>
+            <a:srgbClr val="101828"/>
           </a:solidFill>
           <a:ln>
             <a:solidFill>
@@ -7668,7 +7889,7 @@
           </a:fontRef>
         </p:style>
         <p:txBody>
-          <a:bodyPr rtlCol="0" anchor="ctr"/>
+          <a:bodyPr rtlCol="0" anchor="ctr" wrap="square"/>
           <a:lstStyle/>
           <a:p>
             <a:pPr algn="ctr">
@@ -7676,10 +7897,11 @@
                 <a:solidFill>
                   <a:srgbClr val="F59E0B"/>
                 </a:solidFill>
+                <a:latin typeface="Trebuchet MS"/>
               </a:defRPr>
             </a:pPr>
             <a:r>
-              <a:t>PostgreSQL / Prisma ORM — $15 / mo (Managed Supabase/Render)</a:t>
+              <a:t>PostgreSQL / Prisma ORM — $15 / mo (Managed Database)</a:t>
             </a:r>
           </a:p>
           <a:p>
@@ -7691,6 +7913,7 @@
                 <a:solidFill>
                   <a:srgbClr val="94A3B8"/>
                 </a:solidFill>
+                <a:latin typeface="Segoe UI"/>
               </a:defRPr>
             </a:pPr>
             <a:r>
@@ -7701,7 +7924,7 @@
       </p:sp>
       <p:sp>
         <p:nvSpPr>
-          <p:cNvPr id="8" name="Rounded Rectangle 7"/>
+          <p:cNvPr id="9" name="Rounded Rectangle 8"/>
           <p:cNvSpPr/>
           <p:nvPr/>
         </p:nvSpPr>
@@ -7714,7 +7937,7 @@
             <a:avLst/>
           </a:prstGeom>
           <a:solidFill>
-            <a:srgbClr val="0F172A"/>
+            <a:srgbClr val="101828"/>
           </a:solidFill>
           <a:ln>
             <a:solidFill>
@@ -7737,7 +7960,7 @@
           </a:fontRef>
         </p:style>
         <p:txBody>
-          <a:bodyPr rtlCol="0" anchor="ctr"/>
+          <a:bodyPr rtlCol="0" anchor="ctr" wrap="square"/>
           <a:lstStyle/>
           <a:p>
             <a:pPr algn="ctr">
@@ -7745,10 +7968,11 @@
                 <a:solidFill>
                   <a:srgbClr val="F59E0B"/>
                 </a:solidFill>
+                <a:latin typeface="Trebuchet MS"/>
               </a:defRPr>
             </a:pPr>
             <a:r>
-              <a:t>Vapi AI Voice Restock Calling — $0.05 / completed call</a:t>
+              <a:t>Vapi Voice AI Restocking — $0.05 / completed call</a:t>
             </a:r>
           </a:p>
           <a:p>
@@ -7760,6 +7984,7 @@
                 <a:solidFill>
                   <a:srgbClr val="94A3B8"/>
                 </a:solidFill>
+                <a:latin typeface="Segoe UI"/>
               </a:defRPr>
             </a:pPr>
             <a:r>
@@ -7770,7 +7995,7 @@
       </p:sp>
       <p:sp>
         <p:nvSpPr>
-          <p:cNvPr id="9" name="Rounded Rectangle 8"/>
+          <p:cNvPr id="10" name="Rounded Rectangle 9"/>
           <p:cNvSpPr/>
           <p:nvPr/>
         </p:nvSpPr>
@@ -7783,7 +8008,7 @@
             <a:avLst/>
           </a:prstGeom>
           <a:solidFill>
-            <a:srgbClr val="0F172A"/>
+            <a:srgbClr val="101828"/>
           </a:solidFill>
           <a:ln>
             <a:solidFill>
@@ -7806,7 +8031,7 @@
           </a:fontRef>
         </p:style>
         <p:txBody>
-          <a:bodyPr rtlCol="0" anchor="ctr"/>
+          <a:bodyPr rtlCol="0" anchor="ctr" wrap="square"/>
           <a:lstStyle/>
           <a:p>
             <a:pPr algn="ctr">
@@ -7814,6 +8039,7 @@
                 <a:solidFill>
                   <a:srgbClr val="F59E0B"/>
                 </a:solidFill>
+                <a:latin typeface="Trebuchet MS"/>
               </a:defRPr>
             </a:pPr>
             <a:r>
@@ -7829,6 +8055,7 @@
                 <a:solidFill>
                   <a:srgbClr val="94A3B8"/>
                 </a:solidFill>
+                <a:latin typeface="Segoe UI"/>
               </a:defRPr>
             </a:pPr>
             <a:r>
@@ -7839,7 +8066,7 @@
       </p:sp>
       <p:sp>
         <p:nvSpPr>
-          <p:cNvPr id="10" name="Rounded Rectangle 9"/>
+          <p:cNvPr id="11" name="Rounded Rectangle 10"/>
           <p:cNvSpPr/>
           <p:nvPr/>
         </p:nvSpPr>
@@ -7852,7 +8079,7 @@
             <a:avLst/>
           </a:prstGeom>
           <a:solidFill>
-            <a:srgbClr val="0F172A"/>
+            <a:srgbClr val="101828"/>
           </a:solidFill>
           <a:ln>
             <a:solidFill>
@@ -7875,7 +8102,7 @@
           </a:fontRef>
         </p:style>
         <p:txBody>
-          <a:bodyPr rtlCol="0" anchor="ctr"/>
+          <a:bodyPr rtlCol="0" anchor="ctr" wrap="square"/>
           <a:lstStyle/>
           <a:p>
             <a:pPr algn="ctr">
@@ -7883,6 +8110,7 @@
                 <a:solidFill>
                   <a:srgbClr val="F59E0B"/>
                 </a:solidFill>
+                <a:latin typeface="Trebuchet MS"/>
               </a:defRPr>
             </a:pPr>
             <a:r>
@@ -7898,6 +8126,7 @@
                 <a:solidFill>
                   <a:srgbClr val="94A3B8"/>
                 </a:solidFill>
+                <a:latin typeface="Segoe UI"/>
               </a:defRPr>
             </a:pPr>
             <a:r>
@@ -7939,7 +8168,7 @@
             <a:avLst/>
           </a:prstGeom>
           <a:solidFill>
-            <a:srgbClr val="090D16"/>
+            <a:srgbClr val="0A0E17"/>
           </a:solidFill>
           <a:ln>
             <a:noFill/>
@@ -7969,14 +8198,57 @@
       </p:sp>
       <p:sp>
         <p:nvSpPr>
-          <p:cNvPr id="3" name="TextBox 2"/>
+          <p:cNvPr id="3" name="Rectangle 2"/>
+          <p:cNvSpPr/>
+          <p:nvPr/>
+        </p:nvSpPr>
+        <p:spPr>
+          <a:xfrm>
+            <a:off x="0" y="0"/>
+            <a:ext cx="12191695" cy="73152"/>
+          </a:xfrm>
+          <a:prstGeom prst="rect">
+            <a:avLst/>
+          </a:prstGeom>
+          <a:solidFill>
+            <a:srgbClr val="F59E0B"/>
+          </a:solidFill>
+          <a:ln>
+            <a:noFill/>
+          </a:ln>
+        </p:spPr>
+        <p:style>
+          <a:lnRef idx="1">
+            <a:schemeClr val="accent1"/>
+          </a:lnRef>
+          <a:fillRef idx="3">
+            <a:schemeClr val="accent1"/>
+          </a:fillRef>
+          <a:effectRef idx="2">
+            <a:schemeClr val="accent1"/>
+          </a:effectRef>
+          <a:fontRef idx="minor">
+            <a:schemeClr val="lt1"/>
+          </a:fontRef>
+        </p:style>
+        <p:txBody>
+          <a:bodyPr rtlCol="0" anchor="ctr"/>
+          <a:lstStyle/>
+          <a:p>
+            <a:pPr algn="ctr"/>
+          </a:p>
+        </p:txBody>
+      </p:sp>
+      <p:sp>
+        <p:nvSpPr>
+          <p:cNvPr id="4" name="TextBox 3"/>
           <p:cNvSpPr txBox="1"/>
           <p:nvPr/>
         </p:nvSpPr>
         <p:spPr>
           <a:xfrm>
             <a:off x="731520" y="365760"/>
-            <a:ext cx="10515600" cy="320040"/>
+            <a:ext cx="10698480" cy="274320"/>
           </a:xfrm>
           <a:prstGeom prst="rect">
             <a:avLst/>
@@ -7984,34 +8256,35 @@
           <a:noFill/>
         </p:spPr>
         <p:txBody>
-          <a:bodyPr wrap="none">
+          <a:bodyPr wrap="square">
             <a:spAutoFit/>
           </a:bodyPr>
           <a:lstStyle/>
           <a:p>
             <a:pPr>
-              <a:defRPr sz="1100" b="1">
+              <a:defRPr sz="1000" b="1">
                 <a:solidFill>
                   <a:srgbClr val="38BDF8"/>
                 </a:solidFill>
+                <a:latin typeface="Segoe UI"/>
               </a:defRPr>
             </a:pPr>
             <a:r>
-              <a:t>MERCHANT ROI</a:t>
-            </a:r>
-          </a:p>
-        </p:txBody>
-      </p:sp>
-      <p:sp>
-        <p:nvSpPr>
-          <p:cNvPr id="4" name="TextBox 3"/>
+              <a:t>SHOPKEEPER ROI</a:t>
+            </a:r>
+          </a:p>
+        </p:txBody>
+      </p:sp>
+      <p:sp>
+        <p:nvSpPr>
+          <p:cNvPr id="5" name="TextBox 4"/>
           <p:cNvSpPr txBox="1"/>
           <p:nvPr/>
         </p:nvSpPr>
         <p:spPr>
           <a:xfrm>
-            <a:off x="731520" y="640080"/>
-            <a:ext cx="10515600" cy="731520"/>
+            <a:off x="731520" y="621792"/>
+            <a:ext cx="10698480" cy="640080"/>
           </a:xfrm>
           <a:prstGeom prst="rect">
             <a:avLst/>
@@ -8019,42 +8292,130 @@
           <a:noFill/>
         </p:spPr>
         <p:txBody>
-          <a:bodyPr wrap="none">
+          <a:bodyPr wrap="square">
             <a:spAutoFit/>
           </a:bodyPr>
           <a:lstStyle/>
           <a:p>
             <a:pPr>
-              <a:defRPr sz="2800" b="1">
+              <a:defRPr sz="2600" b="1">
                 <a:solidFill>
                   <a:srgbClr val="F8FAFC"/>
                 </a:solidFill>
+                <a:latin typeface="Trebuchet MS"/>
               </a:defRPr>
             </a:pPr>
             <a:r>
-              <a:t>Shopkeeper Value Realization: The No-Brainer ROI</a:t>
-            </a:r>
-          </a:p>
-        </p:txBody>
-      </p:sp>
-      <p:sp>
-        <p:nvSpPr>
-          <p:cNvPr id="5" name="Rounded Rectangle 4"/>
+              <a:t>Merchant Value Realization: The Irresistible ₹35,000/mo ROI</a:t>
+            </a:r>
+          </a:p>
+        </p:txBody>
+      </p:sp>
+      <p:sp>
+        <p:nvSpPr>
+          <p:cNvPr id="6" name="Rounded Rectangle 5"/>
           <p:cNvSpPr/>
           <p:nvPr/>
         </p:nvSpPr>
         <p:spPr>
           <a:xfrm>
-            <a:off x="731520" y="2011680"/>
-            <a:ext cx="2560320" cy="3657600"/>
+            <a:off x="731520" y="1737360"/>
+            <a:ext cx="2560320" cy="4297680"/>
           </a:xfrm>
           <a:prstGeom prst="roundRect">
             <a:avLst/>
           </a:prstGeom>
           <a:solidFill>
-            <a:srgbClr val="0F172A"/>
+            <a:srgbClr val="101828"/>
           </a:solidFill>
-          <a:ln>
+          <a:ln w="25400">
+            <a:solidFill>
+              <a:srgbClr val="EF4444"/>
+            </a:solidFill>
+          </a:ln>
+        </p:spPr>
+        <p:style>
+          <a:lnRef idx="1">
+            <a:schemeClr val="accent1"/>
+          </a:lnRef>
+          <a:fillRef idx="3">
+            <a:schemeClr val="accent1"/>
+          </a:fillRef>
+          <a:effectRef idx="2">
+            <a:schemeClr val="accent1"/>
+          </a:effectRef>
+          <a:fontRef idx="minor">
+            <a:schemeClr val="lt1"/>
+          </a:fontRef>
+        </p:style>
+        <p:txBody>
+          <a:bodyPr rtlCol="0" anchor="ctr" wrap="square"/>
+          <a:lstStyle/>
+          <a:p>
+            <a:pPr algn="ctr">
+              <a:defRPr sz="1100" b="1">
+                <a:solidFill>
+                  <a:srgbClr val="EF4444"/>
+                </a:solidFill>
+                <a:latin typeface="Segoe UI"/>
+              </a:defRPr>
+            </a:pPr>
+            <a:r>
+              <a:t>STOCKOUT &amp; LEAK PREVENTION</a:t>
+            </a:r>
+          </a:p>
+          <a:p>
+            <a:pPr>
+              <a:spcBef>
+                <a:spcPts val="1000"/>
+              </a:spcBef>
+              <a:defRPr sz="2800" b="1">
+                <a:solidFill>
+                  <a:srgbClr val="F8FAFC"/>
+                </a:solidFill>
+                <a:latin typeface="Trebuchet MS"/>
+              </a:defRPr>
+            </a:pPr>
+            <a:r>
+              <a:t>₹18,000 / mo</a:t>
+            </a:r>
+          </a:p>
+          <a:p>
+            <a:pPr>
+              <a:spcBef>
+                <a:spcPts val="1400"/>
+              </a:spcBef>
+              <a:defRPr sz="1200">
+                <a:solidFill>
+                  <a:srgbClr val="94A3B8"/>
+                </a:solidFill>
+                <a:latin typeface="Segoe UI"/>
+              </a:defRPr>
+            </a:pPr>
+            <a:r>
+              <a:t>FIFO expiry radar and automated reorder alerts prevent perishable goods from rotting on shelves.</a:t>
+            </a:r>
+          </a:p>
+        </p:txBody>
+      </p:sp>
+      <p:sp>
+        <p:nvSpPr>
+          <p:cNvPr id="7" name="Rounded Rectangle 6"/>
+          <p:cNvSpPr/>
+          <p:nvPr/>
+        </p:nvSpPr>
+        <p:spPr>
+          <a:xfrm>
+            <a:off x="3429000" y="1737360"/>
+            <a:ext cx="2560320" cy="4297680"/>
+          </a:xfrm>
+          <a:prstGeom prst="roundRect">
+            <a:avLst/>
+          </a:prstGeom>
+          <a:solidFill>
+            <a:srgbClr val="101828"/>
+          </a:solidFill>
+          <a:ln w="25400">
             <a:solidFill>
               <a:srgbClr val="F59E0B"/>
             </a:solidFill>
@@ -8075,18 +8436,19 @@
           </a:fontRef>
         </p:style>
         <p:txBody>
-          <a:bodyPr rtlCol="0" anchor="ctr"/>
+          <a:bodyPr rtlCol="0" anchor="ctr" wrap="square"/>
           <a:lstStyle/>
           <a:p>
             <a:pPr algn="ctr">
-              <a:defRPr sz="2600" b="1">
+              <a:defRPr sz="1100" b="1">
                 <a:solidFill>
                   <a:srgbClr val="F59E0B"/>
                 </a:solidFill>
+                <a:latin typeface="Segoe UI"/>
               </a:defRPr>
             </a:pPr>
             <a:r>
-              <a:t>₹18,000 / mo</a:t>
+              <a:t>THERMAL PAPER SAVINGS</a:t>
             </a:r>
           </a:p>
           <a:p>
@@ -8094,51 +8456,53 @@
               <a:spcBef>
                 <a:spcPts val="1000"/>
               </a:spcBef>
-              <a:defRPr sz="1400" b="1">
+              <a:defRPr sz="2800" b="1">
                 <a:solidFill>
                   <a:srgbClr val="F8FAFC"/>
                 </a:solidFill>
+                <a:latin typeface="Trebuchet MS"/>
               </a:defRPr>
             </a:pPr>
             <a:r>
-              <a:t>Stockout &amp; Leak Prevention</a:t>
+              <a:t>₹1,800 / mo</a:t>
             </a:r>
           </a:p>
           <a:p>
             <a:pPr>
               <a:spcBef>
-                <a:spcPts val="1000"/>
+                <a:spcPts val="1400"/>
               </a:spcBef>
-              <a:defRPr sz="1100">
+              <a:defRPr sz="1200">
                 <a:solidFill>
                   <a:srgbClr val="94A3B8"/>
                 </a:solidFill>
+                <a:latin typeface="Segoe UI"/>
               </a:defRPr>
             </a:pPr>
             <a:r>
-              <a:t>FIFO expiry radar and automated reorder alerts prevent perishable goods from rotting.</a:t>
-            </a:r>
-          </a:p>
-        </p:txBody>
-      </p:sp>
-      <p:sp>
-        <p:nvSpPr>
-          <p:cNvPr id="6" name="Rounded Rectangle 5"/>
+              <a:t>Switching 1,200 monthly receipts to digital WhatsApp shares saves on physical thermal roll purchases.</a:t>
+            </a:r>
+          </a:p>
+        </p:txBody>
+      </p:sp>
+      <p:sp>
+        <p:nvSpPr>
+          <p:cNvPr id="8" name="Rounded Rectangle 7"/>
           <p:cNvSpPr/>
           <p:nvPr/>
         </p:nvSpPr>
         <p:spPr>
           <a:xfrm>
-            <a:off x="3429000" y="2011680"/>
-            <a:ext cx="2560320" cy="3657600"/>
+            <a:off x="6126480" y="1737360"/>
+            <a:ext cx="2560320" cy="4297680"/>
           </a:xfrm>
           <a:prstGeom prst="roundRect">
             <a:avLst/>
           </a:prstGeom>
           <a:solidFill>
-            <a:srgbClr val="0F172A"/>
+            <a:srgbClr val="101828"/>
           </a:solidFill>
-          <a:ln>
+          <a:ln w="25400">
             <a:solidFill>
               <a:srgbClr val="38BDF8"/>
             </a:solidFill>
@@ -8159,18 +8523,19 @@
           </a:fontRef>
         </p:style>
         <p:txBody>
-          <a:bodyPr rtlCol="0" anchor="ctr"/>
+          <a:bodyPr rtlCol="0" anchor="ctr" wrap="square"/>
           <a:lstStyle/>
           <a:p>
             <a:pPr algn="ctr">
-              <a:defRPr sz="2600" b="1">
+              <a:defRPr sz="1100" b="1">
                 <a:solidFill>
                   <a:srgbClr val="38BDF8"/>
                 </a:solidFill>
+                <a:latin typeface="Segoe UI"/>
               </a:defRPr>
             </a:pPr>
             <a:r>
-              <a:t>₹1,800 / mo</a:t>
+              <a:t>TIME SAVED IN BILLING</a:t>
             </a:r>
           </a:p>
           <a:p>
@@ -8178,53 +8543,55 @@
               <a:spcBef>
                 <a:spcPts val="1000"/>
               </a:spcBef>
-              <a:defRPr sz="1400" b="1">
+              <a:defRPr sz="2800" b="1">
                 <a:solidFill>
                   <a:srgbClr val="F8FAFC"/>
                 </a:solidFill>
+                <a:latin typeface="Trebuchet MS"/>
               </a:defRPr>
             </a:pPr>
             <a:r>
-              <a:t>Thermal Paper Savings</a:t>
+              <a:t>₹12,000 / mo</a:t>
             </a:r>
           </a:p>
           <a:p>
             <a:pPr>
               <a:spcBef>
-                <a:spcPts val="1000"/>
+                <a:spcPts val="1400"/>
               </a:spcBef>
-              <a:defRPr sz="1100">
+              <a:defRPr sz="1200">
                 <a:solidFill>
                   <a:srgbClr val="94A3B8"/>
                 </a:solidFill>
+                <a:latin typeface="Segoe UI"/>
               </a:defRPr>
             </a:pPr>
             <a:r>
-              <a:t>Switching 1,200 monthly receipts to digital WhatsApp shares saves on paper rolls.</a:t>
-            </a:r>
-          </a:p>
-        </p:txBody>
-      </p:sp>
-      <p:sp>
-        <p:nvSpPr>
-          <p:cNvPr id="7" name="Rounded Rectangle 6"/>
+              <a:t>Cuts customer checkout time by 60% and eliminates 2 hours of daily manual pen-and-paper accounting.</a:t>
+            </a:r>
+          </a:p>
+        </p:txBody>
+      </p:sp>
+      <p:sp>
+        <p:nvSpPr>
+          <p:cNvPr id="9" name="Rounded Rectangle 8"/>
           <p:cNvSpPr/>
           <p:nvPr/>
         </p:nvSpPr>
         <p:spPr>
           <a:xfrm>
-            <a:off x="6126480" y="2011680"/>
-            <a:ext cx="2560320" cy="3657600"/>
+            <a:off x="8823960" y="1737360"/>
+            <a:ext cx="2560320" cy="4297680"/>
           </a:xfrm>
           <a:prstGeom prst="roundRect">
             <a:avLst/>
           </a:prstGeom>
           <a:solidFill>
-            <a:srgbClr val="0F172A"/>
+            <a:srgbClr val="101828"/>
           </a:solidFill>
-          <a:ln>
+          <a:ln w="25400">
             <a:solidFill>
-              <a:srgbClr val="38BDF8"/>
+              <a:srgbClr val="10B981"/>
             </a:solidFill>
           </a:ln>
         </p:spPr>
@@ -8243,18 +8610,19 @@
           </a:fontRef>
         </p:style>
         <p:txBody>
-          <a:bodyPr rtlCol="0" anchor="ctr"/>
+          <a:bodyPr rtlCol="0" anchor="ctr" wrap="square"/>
           <a:lstStyle/>
           <a:p>
             <a:pPr algn="ctr">
-              <a:defRPr sz="2600" b="1">
+              <a:defRPr sz="1100" b="1">
                 <a:solidFill>
-                  <a:srgbClr val="38BDF8"/>
+                  <a:srgbClr val="10B981"/>
                 </a:solidFill>
+                <a:latin typeface="Segoe UI"/>
               </a:defRPr>
             </a:pPr>
             <a:r>
-              <a:t>₹12,000 / mo</a:t>
+              <a:t>INCREMENTAL ONLINE ORDERS</a:t>
             </a:r>
           </a:p>
           <a:p>
@@ -8262,109 +8630,27 @@
               <a:spcBef>
                 <a:spcPts val="1000"/>
               </a:spcBef>
-              <a:defRPr sz="1400" b="1">
+              <a:defRPr sz="2800" b="1">
                 <a:solidFill>
                   <a:srgbClr val="F8FAFC"/>
                 </a:solidFill>
+                <a:latin typeface="Trebuchet MS"/>
               </a:defRPr>
             </a:pPr>
             <a:r>
-              <a:t>Time Saved in Billing</a:t>
+              <a:t>₹3,500 / mo</a:t>
             </a:r>
           </a:p>
           <a:p>
             <a:pPr>
               <a:spcBef>
-                <a:spcPts val="1000"/>
+                <a:spcPts val="1400"/>
               </a:spcBef>
-              <a:defRPr sz="1100">
+              <a:defRPr sz="1200">
                 <a:solidFill>
                   <a:srgbClr val="94A3B8"/>
                 </a:solidFill>
-              </a:defRPr>
-            </a:pPr>
-            <a:r>
-              <a:t>Cuts checkout time by 60% and eliminates 2 hours of daily manual pen-and-paper accounting.</a:t>
-            </a:r>
-          </a:p>
-        </p:txBody>
-      </p:sp>
-      <p:sp>
-        <p:nvSpPr>
-          <p:cNvPr id="8" name="Rounded Rectangle 7"/>
-          <p:cNvSpPr/>
-          <p:nvPr/>
-        </p:nvSpPr>
-        <p:spPr>
-          <a:xfrm>
-            <a:off x="8823960" y="2011680"/>
-            <a:ext cx="2560320" cy="3657600"/>
-          </a:xfrm>
-          <a:prstGeom prst="roundRect">
-            <a:avLst/>
-          </a:prstGeom>
-          <a:solidFill>
-            <a:srgbClr val="0F172A"/>
-          </a:solidFill>
-          <a:ln>
-            <a:solidFill>
-              <a:srgbClr val="38BDF8"/>
-            </a:solidFill>
-          </a:ln>
-        </p:spPr>
-        <p:style>
-          <a:lnRef idx="1">
-            <a:schemeClr val="accent1"/>
-          </a:lnRef>
-          <a:fillRef idx="3">
-            <a:schemeClr val="accent1"/>
-          </a:fillRef>
-          <a:effectRef idx="2">
-            <a:schemeClr val="accent1"/>
-          </a:effectRef>
-          <a:fontRef idx="minor">
-            <a:schemeClr val="lt1"/>
-          </a:fontRef>
-        </p:style>
-        <p:txBody>
-          <a:bodyPr rtlCol="0" anchor="ctr"/>
-          <a:lstStyle/>
-          <a:p>
-            <a:pPr algn="ctr">
-              <a:defRPr sz="2600" b="1">
-                <a:solidFill>
-                  <a:srgbClr val="38BDF8"/>
-                </a:solidFill>
-              </a:defRPr>
-            </a:pPr>
-            <a:r>
-              <a:t>₹3,500 / mo</a:t>
-            </a:r>
-          </a:p>
-          <a:p>
-            <a:pPr>
-              <a:spcBef>
-                <a:spcPts val="1000"/>
-              </a:spcBef>
-              <a:defRPr sz="1400" b="1">
-                <a:solidFill>
-                  <a:srgbClr val="F8FAFC"/>
-                </a:solidFill>
-              </a:defRPr>
-            </a:pPr>
-            <a:r>
-              <a:t>Incremental Online Orders</a:t>
-            </a:r>
-          </a:p>
-          <a:p>
-            <a:pPr>
-              <a:spcBef>
-                <a:spcPts val="1000"/>
-              </a:spcBef>
-              <a:defRPr sz="1100">
-                <a:solidFill>
-                  <a:srgbClr val="94A3B8"/>
-                </a:solidFill>
+                <a:latin typeface="Segoe UI"/>
               </a:defRPr>
             </a:pPr>
             <a:r>

</xml_diff>